<commit_message>
Update showcase deck: new features + embedded demo walkthrough
- Slide 3 (Overview): "Original by default" now reads grounded on real sources,
  answer-checked, and self-corrected.
- Slide 6 (Originality): closing line notes output is source-grounded and
  answer-checked, not just plagiarism-clean.
- Slide 8 (Status/Demo): replaced the "Walkthrough GIF" placeholder with an
  embedded animated walkthrough (landing → from-scratch config → generated +
  verified questions with the process timeline → AI edit), lightly framed.
- Slide 9 (Roadmap NOW): surfaced the shipped features — web-grounded +
  answer-checked originality, inline plagiarism self-correction + auto-revamp,
  edit any question (manual or AI). NEXT still holds Judge0, auto-scale by skill,
  and direct Mettl upload.

Verified each edited slide renders correctly. Demo assets kept out of git
(deck_assets/ gitignored); the GIF is embedded inside the .pptx.

Co-Authored-By: Claude Opus 4.8 (1M context) <noreply@anthropic.com>
</commit_message>
<xml_diff>
--- a/MCQ_GenAI_Creation_Showcase.pptx.pptx
+++ b/MCQ_GenAI_Creation_Showcase.pptx.pptx
@@ -10329,7 +10329,7 @@
                   <a:cs typeface="Calibri (MS)"/>
                   <a:sym typeface="Calibri (MS)"/>
                 </a:rPr>
-                <a:t>Checked and self-corrected before any output reaches you.</a:t>
+                <a:t>Grounded on real sources, answer-checked, and self-corrected before anything reaches you.</a:t>
               </a:r>
             </a:p>
           </p:txBody>
@@ -16563,7 +16563,7 @@
                   <a:cs typeface="Calibri (MS) Bold"/>
                   <a:sym typeface="Calibri (MS) Bold"/>
                 </a:rPr>
-                <a:t>What comes back is final — original items that protect test validity, with no separate review step.</a:t>
+                <a:t>What comes back is final — original, source-grounded, and answer-checked — protecting test validity with no separate review step.</a:t>
               </a:r>
             </a:p>
           </p:txBody>
@@ -19516,265 +19516,35 @@
           </p:txBody>
         </p:sp>
       </p:grpSp>
-      <p:grpSp>
-        <p:nvGrpSpPr>
-          <p:cNvPr name="Group 38" id="38"/>
-          <p:cNvGrpSpPr/>
+      <p:pic>
+        <p:nvPicPr>
+          <p:cNvPr id="38" name="Picture 37" descr="walkthrough.gif"/>
+          <p:cNvPicPr>
+            <a:picLocks noChangeAspect="1"/>
+          </p:cNvPicPr>
           <p:nvPr/>
-        </p:nvGrpSpPr>
-        <p:grpSpPr>
-          <a:xfrm rot="0">
-            <a:off x="13681710" y="5006340"/>
-            <a:ext cx="822960" cy="822960"/>
-            <a:chOff x="0" y="0"/>
-            <a:chExt cx="1097280" cy="1097280"/>
-          </a:xfrm>
-        </p:grpSpPr>
-        <p:sp>
-          <p:nvSpPr>
-            <p:cNvPr name="Freeform 39" id="39" descr="preencoded.png"/>
-            <p:cNvSpPr/>
-            <p:nvPr/>
-          </p:nvSpPr>
-          <p:spPr>
-            <a:xfrm flipH="false" flipV="false" rot="0">
-              <a:off x="0" y="0"/>
-              <a:ext cx="1097280" cy="1097280"/>
-            </a:xfrm>
-            <a:custGeom>
-              <a:avLst/>
-              <a:gdLst/>
-              <a:ahLst/>
-              <a:cxnLst/>
-              <a:rect r="r" b="b" t="t" l="l"/>
-              <a:pathLst>
-                <a:path h="1097280" w="1097280">
-                  <a:moveTo>
-                    <a:pt x="0" y="0"/>
-                  </a:moveTo>
-                  <a:lnTo>
-                    <a:pt x="1097280" y="0"/>
-                  </a:lnTo>
-                  <a:lnTo>
-                    <a:pt x="1097280" y="1097280"/>
-                  </a:lnTo>
-                  <a:lnTo>
-                    <a:pt x="0" y="1097280"/>
-                  </a:lnTo>
-                  <a:lnTo>
-                    <a:pt x="0" y="0"/>
-                  </a:lnTo>
-                  <a:close/>
-                </a:path>
-              </a:pathLst>
-            </a:custGeom>
-            <a:blipFill>
-              <a:blip r:embed="rId7"/>
-              <a:stretch>
-                <a:fillRect l="0" t="0" r="0" b="0"/>
-              </a:stretch>
-            </a:blipFill>
-          </p:spPr>
-        </p:sp>
-      </p:grpSp>
-      <p:grpSp>
-        <p:nvGrpSpPr>
-          <p:cNvPr name="Group 40" id="40"/>
-          <p:cNvGrpSpPr/>
-          <p:nvPr/>
-        </p:nvGrpSpPr>
-        <p:grpSpPr>
-          <a:xfrm rot="0">
-            <a:off x="10904220" y="5966460"/>
-            <a:ext cx="6377940" cy="480060"/>
-            <a:chOff x="0" y="0"/>
-            <a:chExt cx="8503920" cy="640080"/>
-          </a:xfrm>
-        </p:grpSpPr>
-        <p:sp>
-          <p:nvSpPr>
-            <p:cNvPr name="Freeform 41" id="41"/>
-            <p:cNvSpPr/>
-            <p:nvPr/>
-          </p:nvSpPr>
-          <p:spPr>
-            <a:xfrm flipH="false" flipV="false" rot="0">
-              <a:off x="0" y="0"/>
-              <a:ext cx="8503920" cy="640080"/>
-            </a:xfrm>
-            <a:custGeom>
-              <a:avLst/>
-              <a:gdLst/>
-              <a:ahLst/>
-              <a:cxnLst/>
-              <a:rect r="r" b="b" t="t" l="l"/>
-              <a:pathLst>
-                <a:path h="640080" w="8503920">
-                  <a:moveTo>
-                    <a:pt x="0" y="0"/>
-                  </a:moveTo>
-                  <a:lnTo>
-                    <a:pt x="8503920" y="0"/>
-                  </a:lnTo>
-                  <a:lnTo>
-                    <a:pt x="8503920" y="640080"/>
-                  </a:lnTo>
-                  <a:lnTo>
-                    <a:pt x="0" y="640080"/>
-                  </a:lnTo>
-                  <a:close/>
-                </a:path>
-              </a:pathLst>
-            </a:custGeom>
-            <a:blipFill>
-              <a:blip r:embed="rId3">
-                <a:alphaModFix amt="0"/>
-              </a:blip>
-              <a:stretch>
-                <a:fillRect l="0" t="-208872" r="0" b="-208872"/>
-              </a:stretch>
-            </a:blipFill>
-          </p:spPr>
-        </p:sp>
-        <p:sp>
-          <p:nvSpPr>
-            <p:cNvPr name="TextBox 42" id="42"/>
-            <p:cNvSpPr txBox="true"/>
-            <p:nvPr/>
-          </p:nvSpPr>
-          <p:spPr>
-            <a:xfrm>
-              <a:off x="0" y="-57150"/>
-              <a:ext cx="8503920" cy="697230"/>
-            </a:xfrm>
-            <a:prstGeom prst="rect">
-              <a:avLst/>
-            </a:prstGeom>
-          </p:spPr>
-          <p:txBody>
-            <a:bodyPr anchor="ctr" rtlCol="false" tIns="0" lIns="0" bIns="0" rIns="0"/>
-            <a:lstStyle/>
-            <a:p>
-              <a:pPr algn="ctr">
-                <a:lnSpc>
-                  <a:spcPts val="2700"/>
-                </a:lnSpc>
-              </a:pPr>
-              <a:r>
-                <a:rPr lang="en-US" sz="2250" b="true">
-                  <a:solidFill>
-                    <a:srgbClr val="003865"/>
-                  </a:solidFill>
-                  <a:latin typeface="Calibri (MS) Bold"/>
-                  <a:ea typeface="Calibri (MS) Bold"/>
-                  <a:cs typeface="Calibri (MS) Bold"/>
-                  <a:sym typeface="Calibri (MS) Bold"/>
-                </a:rPr>
-                <a:t>Walkthrough GIF</a:t>
-              </a:r>
-            </a:p>
-          </p:txBody>
-        </p:sp>
-      </p:grpSp>
-      <p:grpSp>
-        <p:nvGrpSpPr>
-          <p:cNvPr name="Group 43" id="43"/>
-          <p:cNvGrpSpPr/>
-          <p:nvPr/>
-        </p:nvGrpSpPr>
-        <p:grpSpPr>
-          <a:xfrm rot="0">
-            <a:off x="10904220" y="6515100"/>
-            <a:ext cx="6377940" cy="480060"/>
-            <a:chOff x="0" y="0"/>
-            <a:chExt cx="8503920" cy="640080"/>
-          </a:xfrm>
-        </p:grpSpPr>
-        <p:sp>
-          <p:nvSpPr>
-            <p:cNvPr name="Freeform 44" id="44"/>
-            <p:cNvSpPr/>
-            <p:nvPr/>
-          </p:nvSpPr>
-          <p:spPr>
-            <a:xfrm flipH="false" flipV="false" rot="0">
-              <a:off x="0" y="0"/>
-              <a:ext cx="8503920" cy="640080"/>
-            </a:xfrm>
-            <a:custGeom>
-              <a:avLst/>
-              <a:gdLst/>
-              <a:ahLst/>
-              <a:cxnLst/>
-              <a:rect r="r" b="b" t="t" l="l"/>
-              <a:pathLst>
-                <a:path h="640080" w="8503920">
-                  <a:moveTo>
-                    <a:pt x="0" y="0"/>
-                  </a:moveTo>
-                  <a:lnTo>
-                    <a:pt x="8503920" y="0"/>
-                  </a:lnTo>
-                  <a:lnTo>
-                    <a:pt x="8503920" y="640080"/>
-                  </a:lnTo>
-                  <a:lnTo>
-                    <a:pt x="0" y="640080"/>
-                  </a:lnTo>
-                  <a:close/>
-                </a:path>
-              </a:pathLst>
-            </a:custGeom>
-            <a:blipFill>
-              <a:blip r:embed="rId3">
-                <a:alphaModFix amt="0"/>
-              </a:blip>
-              <a:stretch>
-                <a:fillRect l="0" t="-208872" r="0" b="-208872"/>
-              </a:stretch>
-            </a:blipFill>
-          </p:spPr>
-        </p:sp>
-        <p:sp>
-          <p:nvSpPr>
-            <p:cNvPr name="TextBox 45" id="45"/>
-            <p:cNvSpPr txBox="true"/>
-            <p:nvPr/>
-          </p:nvSpPr>
-          <p:spPr>
-            <a:xfrm>
-              <a:off x="0" y="-38100"/>
-              <a:ext cx="8503920" cy="678180"/>
-            </a:xfrm>
-            <a:prstGeom prst="rect">
-              <a:avLst/>
-            </a:prstGeom>
-          </p:spPr>
-          <p:txBody>
-            <a:bodyPr anchor="ctr" rtlCol="false" tIns="0" lIns="0" bIns="0" rIns="0"/>
-            <a:lstStyle/>
-            <a:p>
-              <a:pPr algn="ctr">
-                <a:lnSpc>
-                  <a:spcPts val="2160"/>
-                </a:lnSpc>
-              </a:pPr>
-              <a:r>
-                <a:rPr lang="en-US" sz="1800" i="true">
-                  <a:solidFill>
-                    <a:srgbClr val="6B7280"/>
-                  </a:solidFill>
-                  <a:latin typeface="Calibri (MS) Italics"/>
-                  <a:ea typeface="Calibri (MS) Italics"/>
-                  <a:cs typeface="Calibri (MS) Italics"/>
-                  <a:sym typeface="Calibri (MS) Italics"/>
-                </a:rPr>
-                <a:t>Screen recording of the tool in action goes here.</a:t>
-              </a:r>
-            </a:p>
-          </p:txBody>
-        </p:sp>
-      </p:grpSp>
+        </p:nvPicPr>
+        <p:blipFill>
+          <a:blip r:embed="rId8"/>
+          <a:stretch>
+            <a:fillRect/>
+          </a:stretch>
+        </p:blipFill>
+        <p:spPr>
+          <a:xfrm>
+            <a:off x="11027664" y="4526280"/>
+            <a:ext cx="6135624" cy="2880360"/>
+          </a:xfrm>
+          <a:prstGeom prst="rect">
+            <a:avLst/>
+          </a:prstGeom>
+          <a:ln w="12700">
+            <a:solidFill>
+              <a:srgbClr val="D3D8E0"/>
+            </a:solidFill>
+          </a:ln>
+        </p:spPr>
+      </p:pic>
     </p:spTree>
   </p:cSld>
   <p:clrMapOvr>
@@ -20672,7 +20442,7 @@
                 <a:cs typeface="Calibri (MS)"/>
                 <a:sym typeface="Calibri (MS)"/>
               </a:rPr>
-              <a:t>Two modes — samples or topic + type</a:t>
+              <a:t>Two modes — samples, or just a topic + type</a:t>
             </a:r>
           </a:p>
           <a:p>
@@ -20693,7 +20463,7 @@
                 <a:cs typeface="Calibri (MS)"/>
                 <a:sym typeface="Calibri (MS)"/>
               </a:rPr>
-              <a:t>Lighter / heavier model selection</a:t>
+              <a:t>Web-grounded, answer-checked originality</a:t>
             </a:r>
           </a:p>
           <a:p>
@@ -20714,7 +20484,7 @@
                 <a:cs typeface="Calibri (MS)"/>
                 <a:sym typeface="Calibri (MS)"/>
               </a:rPr>
-              <a:t>Inline plagiarism self-correction</a:t>
+              <a:t>Inline plagiarism self-correction + auto-revamp</a:t>
             </a:r>
           </a:p>
           <a:p>
@@ -20735,7 +20505,7 @@
                 <a:cs typeface="Calibri (MS)"/>
                 <a:sym typeface="Calibri (MS)"/>
               </a:rPr>
-              <a:t>Parallel batch generation — 50 at a time</a:t>
+              <a:t>Edit any question — manually or with AI</a:t>
             </a:r>
           </a:p>
           <a:p>
@@ -20756,7 +20526,7 @@
                 <a:cs typeface="Calibri (MS)"/>
                 <a:sym typeface="Calibri (MS)"/>
               </a:rPr>
-              <a:t>Export in Mettl bulk-upload format</a:t>
+              <a:t>Parallel batches of 50 · Mettl-ready export</a:t>
             </a:r>
           </a:p>
         </p:txBody>

</xml_diff>